<commit_message>
added scritps for interim report
</commit_message>
<xml_diff>
--- a/G1_MotoChain_RideTrue_INTERIM_REPORTpptx.pptx
+++ b/G1_MotoChain_RideTrue_INTERIM_REPORTpptx.pptx
@@ -497,6 +497,2206 @@
     </a:lvl9pPr>
   </p:notesStyle>
 </p:notesMaster>
+</file>
+
+<file path=ppt/notesSlides/notesSlide1.xml><?xml version="1.0" encoding="utf-8"?>
+<p:notes xmlns:a="http://schemas.openxmlformats.org/drawingml/2006/main" xmlns:p="http://schemas.openxmlformats.org/presentationml/2006/main" xmlns:r="http://schemas.openxmlformats.org/officeDocument/2006/relationships">
+  <p:cSld>
+    <p:spTree>
+      <p:nvGrpSpPr>
+        <p:cNvPr id="1" name=""/>
+        <p:cNvGrpSpPr/>
+        <p:nvPr/>
+      </p:nvGrpSpPr>
+      <p:grpSpPr>
+        <a:xfrm>
+          <a:off x="0" y="0"/>
+          <a:ext cx="0" cy="0"/>
+          <a:chOff x="0" y="0"/>
+          <a:chExt cx="0" cy="0"/>
+        </a:xfrm>
+      </p:grpSpPr>
+      <p:sp>
+        <p:nvSpPr>
+          <p:cNvPr id="2" name="Slide Image Placeholder 1"/>
+          <p:cNvSpPr>
+            <a:spLocks noGrp="1"/>
+          </p:cNvSpPr>
+          <p:nvPr>
+            <p:ph type="sldImg" idx="2"/>
+          </p:nvPr>
+        </p:nvSpPr>
+        <p:spPr/>
+      </p:sp>
+      <p:sp>
+        <p:nvSpPr>
+          <p:cNvPr id="3" name="Notes Placeholder 2"/>
+          <p:cNvSpPr>
+            <a:spLocks noGrp="1"/>
+          </p:cNvSpPr>
+          <p:nvPr>
+            <p:ph type="body" idx="3" sz="quarter"/>
+          </p:nvPr>
+        </p:nvSpPr>
+        <p:spPr/>
+        <p:txBody>
+          <a:bodyPr/>
+          <a:lstStyle/>
+          <a:p>
+            <a:r>
+              <a:t>Good [morning/afternoon], everyone. We're Group 1 — Mireu Kim and Enxhi Topalli — and today we're presenting our interim report on MotoChain and RideTrue.</a:t>
+            </a:r>
+          </a:p>
+          <a:p/>
+          <a:p>
+            <a:r>
+              <a:t>MotoChain is a decentralized identity layer for motorcycles, and RideTrue is a behavior-based insurance protocol for riders. Together they form a dual-protocol DeFi system addressing a structural trust problem in two large markets.</a:t>
+            </a:r>
+          </a:p>
+          <a:p/>
+          <a:p>
+            <a:r>
+              <a:t>This is our interim report, so we'll walk you through our problem framing, system design, financials, and risk plan. Let's start with the problem.</a:t>
+            </a:r>
+          </a:p>
+        </p:txBody>
+      </p:sp>
+      <p:sp>
+        <p:nvSpPr>
+          <p:cNvPr id="4" name="Slide Number Placeholder 3"/>
+          <p:cNvSpPr>
+            <a:spLocks noGrp="1"/>
+          </p:cNvSpPr>
+          <p:nvPr>
+            <p:ph type="sldNum" idx="5" sz="quarter"/>
+          </p:nvPr>
+        </p:nvSpPr>
+        <p:spPr/>
+      </p:sp>
+    </p:spTree>
+  </p:cSld>
+  <p:clrMapOvr>
+    <a:masterClrMapping/>
+  </p:clrMapOvr>
+</p:notes>
+</file>
+
+<file path=ppt/notesSlides/notesSlide10.xml><?xml version="1.0" encoding="utf-8"?>
+<p:notes xmlns:a="http://schemas.openxmlformats.org/drawingml/2006/main" xmlns:p="http://schemas.openxmlformats.org/presentationml/2006/main" xmlns:r="http://schemas.openxmlformats.org/officeDocument/2006/relationships">
+  <p:cSld>
+    <p:spTree>
+      <p:nvGrpSpPr>
+        <p:cNvPr id="1" name=""/>
+        <p:cNvGrpSpPr/>
+        <p:nvPr/>
+      </p:nvGrpSpPr>
+      <p:grpSpPr>
+        <a:xfrm>
+          <a:off x="0" y="0"/>
+          <a:ext cx="0" cy="0"/>
+          <a:chOff x="0" y="0"/>
+          <a:chExt cx="0" cy="0"/>
+        </a:xfrm>
+      </p:grpSpPr>
+      <p:sp>
+        <p:nvSpPr>
+          <p:cNvPr id="2" name="Slide Image Placeholder 1"/>
+          <p:cNvSpPr>
+            <a:spLocks noGrp="1"/>
+          </p:cNvSpPr>
+          <p:nvPr>
+            <p:ph type="sldImg" idx="2"/>
+          </p:nvPr>
+        </p:nvSpPr>
+        <p:spPr/>
+      </p:sp>
+      <p:sp>
+        <p:nvSpPr>
+          <p:cNvPr id="3" name="Notes Placeholder 2"/>
+          <p:cNvSpPr>
+            <a:spLocks noGrp="1"/>
+          </p:cNvSpPr>
+          <p:nvPr>
+            <p:ph type="body" idx="3" sz="quarter"/>
+          </p:nvPr>
+        </p:nvSpPr>
+        <p:spPr/>
+        <p:txBody>
+          <a:bodyPr/>
+          <a:lstStyle/>
+          <a:p>
+            <a:r>
+              <a:t>MotoChain and RideTrue is a multi-sided marketplace. We need four participant classes to show up simultaneously: riders and buyers on the demand side, mechanics and dealers on the supply side, liquidity providers providing capital, and insurers and lenders as B2B data consumers.</a:t>
+            </a:r>
+          </a:p>
+          <a:p/>
+          <a:p>
+            <a:r>
+              <a:t>The cold-start problem in multi-sided markets is real. Our solution is to anchor on one side first: dealers.</a:t>
+            </a:r>
+          </a:p>
+          <a:p/>
+          <a:p>
+            <a:r>
+              <a:t>The Seoul wedge: we start by partnering with a small number of high-volume used-bike dealers and repair shops in one dense urban market. Dealers have a direct financial incentive — verified histories let them sell faster, at higher prices, with fewer disputes. Once dealers are enrolled, the bikes are on-chain. Once bikes are on-chain, riders need MotoChain for their insurance score. Once riders are active, B2B partners have data worth paying for.</a:t>
+            </a:r>
+          </a:p>
+          <a:p/>
+          <a:p>
+            <a:r>
+              <a:t>Win the dealers in Seoul. The rest of the network follows.</a:t>
+            </a:r>
+          </a:p>
+        </p:txBody>
+      </p:sp>
+      <p:sp>
+        <p:nvSpPr>
+          <p:cNvPr id="4" name="Slide Number Placeholder 3"/>
+          <p:cNvSpPr>
+            <a:spLocks noGrp="1"/>
+          </p:cNvSpPr>
+          <p:nvPr>
+            <p:ph type="sldNum" idx="5" sz="quarter"/>
+          </p:nvPr>
+        </p:nvSpPr>
+        <p:spPr/>
+      </p:sp>
+    </p:spTree>
+  </p:cSld>
+  <p:clrMapOvr>
+    <a:masterClrMapping/>
+  </p:clrMapOvr>
+</p:notes>
+</file>
+
+<file path=ppt/notesSlides/notesSlide11.xml><?xml version="1.0" encoding="utf-8"?>
+<p:notes xmlns:a="http://schemas.openxmlformats.org/drawingml/2006/main" xmlns:p="http://schemas.openxmlformats.org/presentationml/2006/main" xmlns:r="http://schemas.openxmlformats.org/officeDocument/2006/relationships">
+  <p:cSld>
+    <p:spTree>
+      <p:nvGrpSpPr>
+        <p:cNvPr id="1" name=""/>
+        <p:cNvGrpSpPr/>
+        <p:nvPr/>
+      </p:nvGrpSpPr>
+      <p:grpSpPr>
+        <a:xfrm>
+          <a:off x="0" y="0"/>
+          <a:ext cx="0" cy="0"/>
+          <a:chOff x="0" y="0"/>
+          <a:chExt cx="0" cy="0"/>
+        </a:xfrm>
+      </p:grpSpPr>
+      <p:sp>
+        <p:nvSpPr>
+          <p:cNvPr id="2" name="Slide Image Placeholder 1"/>
+          <p:cNvSpPr>
+            <a:spLocks noGrp="1"/>
+          </p:cNvSpPr>
+          <p:nvPr>
+            <p:ph type="sldImg" idx="2"/>
+          </p:nvPr>
+        </p:nvSpPr>
+        <p:spPr/>
+      </p:sp>
+      <p:sp>
+        <p:nvSpPr>
+          <p:cNvPr id="3" name="Notes Placeholder 2"/>
+          <p:cNvSpPr>
+            <a:spLocks noGrp="1"/>
+          </p:cNvSpPr>
+          <p:nvPr>
+            <p:ph type="body" idx="3" sz="quarter"/>
+          </p:nvPr>
+        </p:nvSpPr>
+        <p:spPr/>
+        <p:txBody>
+          <a:bodyPr/>
+          <a:lstStyle/>
+          <a:p>
+            <a:r>
+              <a:t>This slide is for anyone who wants to understand how RideTrue works at the user level, without the technical details.</a:t>
+            </a:r>
+          </a:p>
+          <a:p/>
+          <a:p>
+            <a:r>
+              <a:t>Step one: something happens — a crash, theft, or damage. Step two: the rider opens the app and files a claim with photos and details. Step three: the oracle system gathers evidence from repair shops, police records, and insurer databases. Step four: validators reach consensus that the claim is legitimate. Step five: USDC is sent directly to the rider's wallet. Step six: the pool automatically adjusts reserves and pricing for the next period.</a:t>
+            </a:r>
+          </a:p>
+          <a:p/>
+          <a:p>
+            <a:r>
+              <a:t>The key takeaway: this process is automated, transparent, and paid in stablecoin. There's no adjuster to call, no check that takes three weeks. The contract pays when the oracles agree.</a:t>
+            </a:r>
+          </a:p>
+        </p:txBody>
+      </p:sp>
+      <p:sp>
+        <p:nvSpPr>
+          <p:cNvPr id="4" name="Slide Number Placeholder 3"/>
+          <p:cNvSpPr>
+            <a:spLocks noGrp="1"/>
+          </p:cNvSpPr>
+          <p:nvPr>
+            <p:ph type="sldNum" idx="5" sz="quarter"/>
+          </p:nvPr>
+        </p:nvSpPr>
+        <p:spPr/>
+      </p:sp>
+    </p:spTree>
+  </p:cSld>
+  <p:clrMapOvr>
+    <a:masterClrMapping/>
+  </p:clrMapOvr>
+</p:notes>
+</file>
+
+<file path=ppt/notesSlides/notesSlide12.xml><?xml version="1.0" encoding="utf-8"?>
+<p:notes xmlns:a="http://schemas.openxmlformats.org/drawingml/2006/main" xmlns:p="http://schemas.openxmlformats.org/presentationml/2006/main" xmlns:r="http://schemas.openxmlformats.org/officeDocument/2006/relationships">
+  <p:cSld>
+    <p:spTree>
+      <p:nvGrpSpPr>
+        <p:cNvPr id="1" name=""/>
+        <p:cNvGrpSpPr/>
+        <p:nvPr/>
+      </p:nvGrpSpPr>
+      <p:grpSpPr>
+        <a:xfrm>
+          <a:off x="0" y="0"/>
+          <a:ext cx="0" cy="0"/>
+          <a:chOff x="0" y="0"/>
+          <a:chExt cx="0" cy="0"/>
+        </a:xfrm>
+      </p:grpSpPr>
+      <p:sp>
+        <p:nvSpPr>
+          <p:cNvPr id="2" name="Slide Image Placeholder 1"/>
+          <p:cNvSpPr>
+            <a:spLocks noGrp="1"/>
+          </p:cNvSpPr>
+          <p:nvPr>
+            <p:ph type="sldImg" idx="2"/>
+          </p:nvPr>
+        </p:nvSpPr>
+        <p:spPr/>
+      </p:sp>
+      <p:sp>
+        <p:nvSpPr>
+          <p:cNvPr id="3" name="Notes Placeholder 2"/>
+          <p:cNvSpPr>
+            <a:spLocks noGrp="1"/>
+          </p:cNvSpPr>
+          <p:nvPr>
+            <p:ph type="body" idx="3" sz="quarter"/>
+          </p:nvPr>
+        </p:nvSpPr>
+        <p:spPr/>
+        <p:txBody>
+          <a:bodyPr/>
+          <a:lstStyle/>
+          <a:p>
+            <a:r>
+              <a:t>Our financial model is grounded in Korean industry data, not aspirational assumptions.</a:t>
+            </a:r>
+          </a:p>
+          <a:p/>
+          <a:p>
+            <a:r>
+              <a:t>Year 1: 5,000 registered motorcycles and 2,000 active RideTrue riders. That's 0.2% of Korea's registered motorcycle fleet — achievable via 5 dealer partnerships in Seoul. Average monthly premium of 90,000 won is the midpoint of the Korean motorcycle insurance range cited by KIDI and FSS.</a:t>
+            </a:r>
+          </a:p>
+          <a:p/>
+          <a:p>
+            <a:r>
+              <a:t>We modeled a loss ratio of about 8.9% — 8% claim frequency times 1.2 million won average severity. That's intentionally conservative. The stress test uses 15% frequency and 2.5 million won severity, and we'll show you that model's output on the stress slide.</a:t>
+            </a:r>
+          </a:p>
+          <a:p/>
+          <a:p>
+            <a:r>
+              <a:t>Mechanic ramp tracks bike count at roughly 1 mechanic per 50 bikes — feasible if dealer partners require MotoChain logging as part of their onboarding process.</a:t>
+            </a:r>
+          </a:p>
+        </p:txBody>
+      </p:sp>
+      <p:sp>
+        <p:nvSpPr>
+          <p:cNvPr id="4" name="Slide Number Placeholder 3"/>
+          <p:cNvSpPr>
+            <a:spLocks noGrp="1"/>
+          </p:cNvSpPr>
+          <p:nvPr>
+            <p:ph type="sldNum" idx="5" sz="quarter"/>
+          </p:nvPr>
+        </p:nvSpPr>
+        <p:spPr/>
+      </p:sp>
+    </p:spTree>
+  </p:cSld>
+  <p:clrMapOvr>
+    <a:masterClrMapping/>
+  </p:clrMapOvr>
+</p:notes>
+</file>
+
+<file path=ppt/notesSlides/notesSlide13.xml><?xml version="1.0" encoding="utf-8"?>
+<p:notes xmlns:a="http://schemas.openxmlformats.org/drawingml/2006/main" xmlns:p="http://schemas.openxmlformats.org/presentationml/2006/main" xmlns:r="http://schemas.openxmlformats.org/officeDocument/2006/relationships">
+  <p:cSld>
+    <p:spTree>
+      <p:nvGrpSpPr>
+        <p:cNvPr id="1" name=""/>
+        <p:cNvGrpSpPr/>
+        <p:nvPr/>
+      </p:nvGrpSpPr>
+      <p:grpSpPr>
+        <a:xfrm>
+          <a:off x="0" y="0"/>
+          <a:ext cx="0" cy="0"/>
+          <a:chOff x="0" y="0"/>
+          <a:chExt cx="0" cy="0"/>
+        </a:xfrm>
+      </p:grpSpPr>
+      <p:sp>
+        <p:nvSpPr>
+          <p:cNvPr id="2" name="Slide Image Placeholder 1"/>
+          <p:cNvSpPr>
+            <a:spLocks noGrp="1"/>
+          </p:cNvSpPr>
+          <p:nvPr>
+            <p:ph type="sldImg" idx="2"/>
+          </p:nvPr>
+        </p:nvSpPr>
+        <p:spPr/>
+      </p:sp>
+      <p:sp>
+        <p:nvSpPr>
+          <p:cNvPr id="3" name="Notes Placeholder 2"/>
+          <p:cNvSpPr>
+            <a:spLocks noGrp="1"/>
+          </p:cNvSpPr>
+          <p:nvPr>
+            <p:ph type="body" idx="3" sz="quarter"/>
+          </p:nvPr>
+        </p:nvSpPr>
+        <p:spPr/>
+        <p:txBody>
+          <a:bodyPr/>
+          <a:lstStyle/>
+          <a:p>
+            <a:r>
+              <a:t>The protocol has six revenue streams in Year 1.</a:t>
+            </a:r>
+          </a:p>
+          <a:p/>
+          <a:p>
+            <a:r>
+              <a:t>VIN registration: 50 million won from 5,000 bikes at 10,000 won each. One-time fee. Ownership transfer: 15 million won from an estimated 1,000 annual resales. Service entries: 10 million won as the protocol's 20% share of verified service record fees. Insurance pool fee: 108 million won — 5% of the 2.16 billion won annual premium pool. This is the largest single stream in Year 1. Claim processing margin: about 1.9 million won, a small 1% admin fee on approved claims. API and data access: 180 million won from 3 B2B partners at 5 million won per month each.</a:t>
+            </a:r>
+          </a:p>
+          <a:p/>
+          <a:p>
+            <a:r>
+              <a:t>Total Year 1 protocol revenue: 365 million won. The insurance pool fee and B2B data subscriptions together represent more than 80% of that.</a:t>
+            </a:r>
+          </a:p>
+        </p:txBody>
+      </p:sp>
+      <p:sp>
+        <p:nvSpPr>
+          <p:cNvPr id="4" name="Slide Number Placeholder 3"/>
+          <p:cNvSpPr>
+            <a:spLocks noGrp="1"/>
+          </p:cNvSpPr>
+          <p:nvPr>
+            <p:ph type="sldNum" idx="5" sz="quarter"/>
+          </p:nvPr>
+        </p:nvSpPr>
+        <p:spPr/>
+      </p:sp>
+    </p:spTree>
+  </p:cSld>
+  <p:clrMapOvr>
+    <a:masterClrMapping/>
+  </p:clrMapOvr>
+</p:notes>
+</file>
+
+<file path=ppt/notesSlides/notesSlide14.xml><?xml version="1.0" encoding="utf-8"?>
+<p:notes xmlns:a="http://schemas.openxmlformats.org/drawingml/2006/main" xmlns:p="http://schemas.openxmlformats.org/presentationml/2006/main" xmlns:r="http://schemas.openxmlformats.org/officeDocument/2006/relationships">
+  <p:cSld>
+    <p:spTree>
+      <p:nvGrpSpPr>
+        <p:cNvPr id="1" name=""/>
+        <p:cNvGrpSpPr/>
+        <p:nvPr/>
+      </p:nvGrpSpPr>
+      <p:grpSpPr>
+        <a:xfrm>
+          <a:off x="0" y="0"/>
+          <a:ext cx="0" cy="0"/>
+          <a:chOff x="0" y="0"/>
+          <a:chExt cx="0" cy="0"/>
+        </a:xfrm>
+      </p:grpSpPr>
+      <p:sp>
+        <p:nvSpPr>
+          <p:cNvPr id="2" name="Slide Image Placeholder 1"/>
+          <p:cNvSpPr>
+            <a:spLocks noGrp="1"/>
+          </p:cNvSpPr>
+          <p:nvPr>
+            <p:ph type="sldImg" idx="2"/>
+          </p:nvPr>
+        </p:nvSpPr>
+        <p:spPr/>
+      </p:sp>
+      <p:sp>
+        <p:nvSpPr>
+          <p:cNvPr id="3" name="Notes Placeholder 2"/>
+          <p:cNvSpPr>
+            <a:spLocks noGrp="1"/>
+          </p:cNvSpPr>
+          <p:nvPr>
+            <p:ph type="body" idx="3" sz="quarter"/>
+          </p:nvPr>
+        </p:nvSpPr>
+        <p:spPr/>
+        <p:txBody>
+          <a:bodyPr/>
+          <a:lstStyle/>
+          <a:p>
+            <a:r>
+              <a:t>Year 1 is the foundation. The growth story is what happens as bike count scales.</a:t>
+            </a:r>
+          </a:p>
+          <a:p/>
+          <a:p>
+            <a:r>
+              <a:t>From Year 1 to Year 3, total protocol revenue grows 21 times — from 365 million to 7.85 billion won. The biggest driver of that growth is the B2B data subscriptions, which scale from 180 million to 3.6 billion won and become the largest single revenue stream at 46% of Year 3 total.</a:t>
+            </a:r>
+          </a:p>
+          <a:p/>
+          <a:p>
+            <a:r>
+              <a:t>By Year 3 we have 100,000 registered motorcycles — which sounds large, but is still only 0.2% of Korea's registered fleet. The growth assumption is 20x via dealer-led acquisition, which scales proportionally with the dealer partnerships we establish in Year 1.</a:t>
+            </a:r>
+          </a:p>
+          <a:p/>
+          <a:p>
+            <a:r>
+              <a:t>Riders track at 40 to 50% of registered bikes. B2B partners grow from 3 to 20 as the dataset matures.</a:t>
+            </a:r>
+          </a:p>
+        </p:txBody>
+      </p:sp>
+      <p:sp>
+        <p:nvSpPr>
+          <p:cNvPr id="4" name="Slide Number Placeholder 3"/>
+          <p:cNvSpPr>
+            <a:spLocks noGrp="1"/>
+          </p:cNvSpPr>
+          <p:nvPr>
+            <p:ph type="sldNum" idx="5" sz="quarter"/>
+          </p:nvPr>
+        </p:nvSpPr>
+        <p:spPr/>
+      </p:sp>
+    </p:spTree>
+  </p:cSld>
+  <p:clrMapOvr>
+    <a:masterClrMapping/>
+  </p:clrMapOvr>
+</p:notes>
+</file>
+
+<file path=ppt/notesSlides/notesSlide15.xml><?xml version="1.0" encoding="utf-8"?>
+<p:notes xmlns:a="http://schemas.openxmlformats.org/drawingml/2006/main" xmlns:p="http://schemas.openxmlformats.org/presentationml/2006/main" xmlns:r="http://schemas.openxmlformats.org/officeDocument/2006/relationships">
+  <p:cSld>
+    <p:spTree>
+      <p:nvGrpSpPr>
+        <p:cNvPr id="1" name=""/>
+        <p:cNvGrpSpPr/>
+        <p:nvPr/>
+      </p:nvGrpSpPr>
+      <p:grpSpPr>
+        <a:xfrm>
+          <a:off x="0" y="0"/>
+          <a:ext cx="0" cy="0"/>
+          <a:chOff x="0" y="0"/>
+          <a:chExt cx="0" cy="0"/>
+        </a:xfrm>
+      </p:grpSpPr>
+      <p:sp>
+        <p:nvSpPr>
+          <p:cNvPr id="2" name="Slide Image Placeholder 1"/>
+          <p:cNvSpPr>
+            <a:spLocks noGrp="1"/>
+          </p:cNvSpPr>
+          <p:nvPr>
+            <p:ph type="sldImg" idx="2"/>
+          </p:nvPr>
+        </p:nvSpPr>
+        <p:spPr/>
+      </p:sp>
+      <p:sp>
+        <p:nvSpPr>
+          <p:cNvPr id="3" name="Notes Placeholder 2"/>
+          <p:cNvSpPr>
+            <a:spLocks noGrp="1"/>
+          </p:cNvSpPr>
+          <p:nvPr>
+            <p:ph type="body" idx="3" sz="quarter"/>
+          </p:nvPr>
+        </p:nvSpPr>
+        <p:spPr/>
+        <p:txBody>
+          <a:bodyPr/>
+          <a:lstStyle/>
+          <a:p>
+            <a:r>
+              <a:t>This slide shows the full money flow for Year 1 — what comes in, what goes out, and what the economics look like for an individual rider.</a:t>
+            </a:r>
+          </a:p>
+          <a:p/>
+          <a:p>
+            <a:r>
+              <a:t>Money in: 2.16 billion won in rider premiums, 3 billion in LP pool capital, and about 90 million more from B2B fees and DeFi yield. Total processed: about 5.25 billion won.</a:t>
+            </a:r>
+          </a:p>
+          <a:p/>
+          <a:p>
+            <a:r>
+              <a:t>Money out: 750 million in claims paid, 216 million in safe-rider rebates, 1.19 billion held in reserves and reinsurance, and 1.8 billion in team and operations costs.</a:t>
+            </a:r>
+          </a:p>
+          <a:p/>
+          <a:p>
+            <a:r>
+              <a:t>To make this concrete: Ji-min, a 28-year-old delivery rider in Seoul with a safety score of 92 out of 100 and zero claims in Year 1. She pays 1,080,000 won over the year — 90,000 a month. As a top-quartile safe rider, she receives a 180,000 won rebate. Net premium: 900,000 won for full-year coverage. Comparable traditional Korean motorcycle insurance for a delivery rider runs 1 to 1.4 million won — with no behavior discount and no on-chain claim settlement.</a:t>
+            </a:r>
+          </a:p>
+        </p:txBody>
+      </p:sp>
+      <p:sp>
+        <p:nvSpPr>
+          <p:cNvPr id="4" name="Slide Number Placeholder 3"/>
+          <p:cNvSpPr>
+            <a:spLocks noGrp="1"/>
+          </p:cNvSpPr>
+          <p:nvPr>
+            <p:ph type="sldNum" idx="5" sz="quarter"/>
+          </p:nvPr>
+        </p:nvSpPr>
+        <p:spPr/>
+      </p:sp>
+    </p:spTree>
+  </p:cSld>
+  <p:clrMapOvr>
+    <a:masterClrMapping/>
+  </p:clrMapOvr>
+</p:notes>
+</file>
+
+<file path=ppt/notesSlides/notesSlide16.xml><?xml version="1.0" encoding="utf-8"?>
+<p:notes xmlns:a="http://schemas.openxmlformats.org/drawingml/2006/main" xmlns:p="http://schemas.openxmlformats.org/presentationml/2006/main" xmlns:r="http://schemas.openxmlformats.org/officeDocument/2006/relationships">
+  <p:cSld>
+    <p:spTree>
+      <p:nvGrpSpPr>
+        <p:cNvPr id="1" name=""/>
+        <p:cNvGrpSpPr/>
+        <p:nvPr/>
+      </p:nvGrpSpPr>
+      <p:grpSpPr>
+        <a:xfrm>
+          <a:off x="0" y="0"/>
+          <a:ext cx="0" cy="0"/>
+          <a:chOff x="0" y="0"/>
+          <a:chExt cx="0" cy="0"/>
+        </a:xfrm>
+      </p:grpSpPr>
+      <p:sp>
+        <p:nvSpPr>
+          <p:cNvPr id="2" name="Slide Image Placeholder 1"/>
+          <p:cNvSpPr>
+            <a:spLocks noGrp="1"/>
+          </p:cNvSpPr>
+          <p:nvPr>
+            <p:ph type="sldImg" idx="2"/>
+          </p:nvPr>
+        </p:nvSpPr>
+        <p:spPr/>
+      </p:sp>
+      <p:sp>
+        <p:nvSpPr>
+          <p:cNvPr id="3" name="Notes Placeholder 2"/>
+          <p:cNvSpPr>
+            <a:spLocks noGrp="1"/>
+          </p:cNvSpPr>
+          <p:nvPr>
+            <p:ph type="body" idx="3" sz="quarter"/>
+          </p:nvPr>
+        </p:nvSpPr>
+        <p:spPr/>
+        <p:txBody>
+          <a:bodyPr/>
+          <a:lstStyle/>
+          <a:p>
+            <a:r>
+              <a:t>We don't assume the model runs perfectly. This slide covers the nine safeguards across three layers that keep the pool standing when many claims hit at once.</a:t>
+            </a:r>
+          </a:p>
+          <a:p/>
+          <a:p>
+            <a:r>
+              <a:t>Reserve layers: 25% of the pool always stays liquid in USDC — never deployed. 20% of every premium is routed to a catastrophe reserve. And we require a reinsurance backstop before launch to cover tail risk above pool capacity.</a:t>
+            </a:r>
+          </a:p>
+          <a:p/>
+          <a:p>
+            <a:r>
+              <a:t>Automatic contract safeguards: a circuit breaker that triggers emergency mode on claim spikes, reserve drops, disaster zones, or 3x volume. Coverage caps at 5 million won for normal claims and 3 million for catastrophes. And DeFi deployment is capped at 10 to 15% of excess reserves, blue-chip protocols only.</a:t>
+            </a:r>
+          </a:p>
+          <a:p/>
+          <a:p>
+            <a:r>
+              <a:t>Crisis playbook: in emergency mode, 50% of claims pay immediately and 50% pays over 3 to 6 months as liquidity returns. If the pool is short, everyone gets a proportional share — fair and transparent. And post-shock, premiums can increase 10 to 20% temporarily to rebuild reserves.</a:t>
+            </a:r>
+          </a:p>
+          <a:p/>
+          <a:p>
+            <a:r>
+              <a:t>We calibrate Korean typhoons as base-case events, not tail events. That's built directly into our catastrophe reserve sizing.</a:t>
+            </a:r>
+          </a:p>
+        </p:txBody>
+      </p:sp>
+      <p:sp>
+        <p:nvSpPr>
+          <p:cNvPr id="4" name="Slide Number Placeholder 3"/>
+          <p:cNvSpPr>
+            <a:spLocks noGrp="1"/>
+          </p:cNvSpPr>
+          <p:nvPr>
+            <p:ph type="sldNum" idx="5" sz="quarter"/>
+          </p:nvPr>
+        </p:nvSpPr>
+        <p:spPr/>
+      </p:sp>
+    </p:spTree>
+  </p:cSld>
+  <p:clrMapOvr>
+    <a:masterClrMapping/>
+  </p:clrMapOvr>
+</p:notes>
+</file>
+
+<file path=ppt/notesSlides/notesSlide17.xml><?xml version="1.0" encoding="utf-8"?>
+<p:notes xmlns:a="http://schemas.openxmlformats.org/drawingml/2006/main" xmlns:p="http://schemas.openxmlformats.org/presentationml/2006/main" xmlns:r="http://schemas.openxmlformats.org/officeDocument/2006/relationships">
+  <p:cSld>
+    <p:spTree>
+      <p:nvGrpSpPr>
+        <p:cNvPr id="1" name=""/>
+        <p:cNvGrpSpPr/>
+        <p:nvPr/>
+      </p:nvGrpSpPr>
+      <p:grpSpPr>
+        <a:xfrm>
+          <a:off x="0" y="0"/>
+          <a:ext cx="0" cy="0"/>
+          <a:chOff x="0" y="0"/>
+          <a:chExt cx="0" cy="0"/>
+        </a:xfrm>
+      </p:grpSpPr>
+      <p:sp>
+        <p:nvSpPr>
+          <p:cNvPr id="2" name="Slide Image Placeholder 1"/>
+          <p:cNvSpPr>
+            <a:spLocks noGrp="1"/>
+          </p:cNvSpPr>
+          <p:nvPr>
+            <p:ph type="sldImg" idx="2"/>
+          </p:nvPr>
+        </p:nvSpPr>
+        <p:spPr/>
+      </p:sp>
+      <p:sp>
+        <p:nvSpPr>
+          <p:cNvPr id="3" name="Notes Placeholder 2"/>
+          <p:cNvSpPr>
+            <a:spLocks noGrp="1"/>
+          </p:cNvSpPr>
+          <p:nvPr>
+            <p:ph type="body" idx="3" sz="quarter"/>
+          </p:nvPr>
+        </p:nvSpPr>
+        <p:spPr/>
+        <p:txBody>
+          <a:bodyPr/>
+          <a:lstStyle/>
+          <a:p>
+            <a:r>
+              <a:t>Our governance and utility token is $MOTO — that's a working name, and the final brand will go through trademark and domain clearance before TGE.</a:t>
+            </a:r>
+          </a:p>
+          <a:p/>
+          <a:p>
+            <a:r>
+              <a:t>Four parameters: the token deploys on Base, EVM-compatible, with average transaction costs under 5 cents versus 5 dollars on Ethereum mainnet. Total supply is 1 billion, fixed cap — no protocol inflation post-TGE. A fixed cap prevents dilution and makes long-term value predictable. Standard is ERC-20 with governance and staking modules, giving maximum compatibility with wallets, DEXes, and custodians across any EVM chain.</a:t>
+            </a:r>
+          </a:p>
+          <a:p/>
+          <a:p>
+            <a:r>
+              <a:t>Everything on this slide is a draft assumption. Final parameters go through legal and token-design advisor review before any public announcement.</a:t>
+            </a:r>
+          </a:p>
+        </p:txBody>
+      </p:sp>
+      <p:sp>
+        <p:nvSpPr>
+          <p:cNvPr id="4" name="Slide Number Placeholder 3"/>
+          <p:cNvSpPr>
+            <a:spLocks noGrp="1"/>
+          </p:cNvSpPr>
+          <p:nvPr>
+            <p:ph type="sldNum" idx="5" sz="quarter"/>
+          </p:nvPr>
+        </p:nvSpPr>
+        <p:spPr/>
+      </p:sp>
+    </p:spTree>
+  </p:cSld>
+  <p:clrMapOvr>
+    <a:masterClrMapping/>
+  </p:clrMapOvr>
+</p:notes>
+</file>
+
+<file path=ppt/notesSlides/notesSlide18.xml><?xml version="1.0" encoding="utf-8"?>
+<p:notes xmlns:a="http://schemas.openxmlformats.org/drawingml/2006/main" xmlns:p="http://schemas.openxmlformats.org/presentationml/2006/main" xmlns:r="http://schemas.openxmlformats.org/officeDocument/2006/relationships">
+  <p:cSld>
+    <p:spTree>
+      <p:nvGrpSpPr>
+        <p:cNvPr id="1" name=""/>
+        <p:cNvGrpSpPr/>
+        <p:nvPr/>
+      </p:nvGrpSpPr>
+      <p:grpSpPr>
+        <a:xfrm>
+          <a:off x="0" y="0"/>
+          <a:ext cx="0" cy="0"/>
+          <a:chOff x="0" y="0"/>
+          <a:chExt cx="0" cy="0"/>
+        </a:xfrm>
+      </p:grpSpPr>
+      <p:sp>
+        <p:nvSpPr>
+          <p:cNvPr id="2" name="Slide Image Placeholder 1"/>
+          <p:cNvSpPr>
+            <a:spLocks noGrp="1"/>
+          </p:cNvSpPr>
+          <p:nvPr>
+            <p:ph type="sldImg" idx="2"/>
+          </p:nvPr>
+        </p:nvSpPr>
+        <p:spPr/>
+      </p:sp>
+      <p:sp>
+        <p:nvSpPr>
+          <p:cNvPr id="3" name="Notes Placeholder 2"/>
+          <p:cNvSpPr>
+            <a:spLocks noGrp="1"/>
+          </p:cNvSpPr>
+          <p:nvPr>
+            <p:ph type="body" idx="3" sz="quarter"/>
+          </p:nvPr>
+        </p:nvSpPr>
+        <p:spPr/>
+        <p:txBody>
+          <a:bodyPr/>
+          <a:lstStyle/>
+          <a:p>
+            <a:r>
+              <a:t>The 1 billion token supply is split across seven buckets, each with a specific rationale and vesting schedule.</a:t>
+            </a:r>
+          </a:p>
+          <a:p/>
+          <a:p>
+            <a:r>
+              <a:t>Community and ecosystem gets 30% — the largest allocation — to fund dealer, mechanic, and rider acquisition. The real-world go-to-market cost is high. Insurance pool subsidy gets 15%, tapered over Years 1 to 3 to bootstrap safe-rider rebates until premium revenue scales on its own. Team and founders get 18% — below the 20 to 25% industry norm, which we think signals alignment with users. Seed investors get 8% with a 2-year vest and 6-month cliff; private investors get 9% with an 18-month vest and 3-month cliff. Treasury and DAO reserve gets 15%, governance-gated. And liquidity provision gets 5%, unlocked at TGE so market-making capital is functional from day one.</a:t>
+            </a:r>
+          </a:p>
+          <a:p/>
+          <a:p>
+            <a:r>
+              <a:t>Key design principle: total insider supply — team plus investors — is capped at 35%. The industry norm is 40 to 50%.</a:t>
+            </a:r>
+          </a:p>
+        </p:txBody>
+      </p:sp>
+      <p:sp>
+        <p:nvSpPr>
+          <p:cNvPr id="4" name="Slide Number Placeholder 3"/>
+          <p:cNvSpPr>
+            <a:spLocks noGrp="1"/>
+          </p:cNvSpPr>
+          <p:nvPr>
+            <p:ph type="sldNum" idx="5" sz="quarter"/>
+          </p:nvPr>
+        </p:nvSpPr>
+        <p:spPr/>
+      </p:sp>
+    </p:spTree>
+  </p:cSld>
+  <p:clrMapOvr>
+    <a:masterClrMapping/>
+  </p:clrMapOvr>
+</p:notes>
+</file>
+
+<file path=ppt/notesSlides/notesSlide19.xml><?xml version="1.0" encoding="utf-8"?>
+<p:notes xmlns:a="http://schemas.openxmlformats.org/drawingml/2006/main" xmlns:p="http://schemas.openxmlformats.org/presentationml/2006/main" xmlns:r="http://schemas.openxmlformats.org/officeDocument/2006/relationships">
+  <p:cSld>
+    <p:spTree>
+      <p:nvGrpSpPr>
+        <p:cNvPr id="1" name=""/>
+        <p:cNvGrpSpPr/>
+        <p:nvPr/>
+      </p:nvGrpSpPr>
+      <p:grpSpPr>
+        <a:xfrm>
+          <a:off x="0" y="0"/>
+          <a:ext cx="0" cy="0"/>
+          <a:chOff x="0" y="0"/>
+          <a:chExt cx="0" cy="0"/>
+        </a:xfrm>
+      </p:grpSpPr>
+      <p:sp>
+        <p:nvSpPr>
+          <p:cNvPr id="2" name="Slide Image Placeholder 1"/>
+          <p:cNvSpPr>
+            <a:spLocks noGrp="1"/>
+          </p:cNvSpPr>
+          <p:nvPr>
+            <p:ph type="sldImg" idx="2"/>
+          </p:nvPr>
+        </p:nvSpPr>
+        <p:spPr/>
+      </p:sp>
+      <p:sp>
+        <p:nvSpPr>
+          <p:cNvPr id="3" name="Notes Placeholder 2"/>
+          <p:cNvSpPr>
+            <a:spLocks noGrp="1"/>
+          </p:cNvSpPr>
+          <p:nvPr>
+            <p:ph type="body" idx="3" sz="quarter"/>
+          </p:nvPr>
+        </p:nvSpPr>
+        <p:spPr/>
+        <p:txBody>
+          <a:bodyPr/>
+          <a:lstStyle/>
+          <a:p>
+            <a:r>
+              <a:t>Every 100 won a rider pays in premium gets allocated across seven buckets.</a:t>
+            </a:r>
+          </a:p>
+          <a:p/>
+          <a:p>
+            <a:r>
+              <a:t>12% to expected claims — that's our modeled 8.9% loss ratio plus a roughly 3% buffer for actuarial drift. 25% to the liquid reserve, kept in USDC and never deployed to yield — above the industry 15 to 20% norm because we have no track record yet. 20% to the catastrophe reserve — sized for Korean typhoon exposure, treated as a base-case event. 10% to the reinsurance premium budget for the external backstop. 18% to safe-rider rebates — generous because our modeled losses are low, and surplus goes back to users. 5% as the protocol fee, aligned with Nexus Mutual's benchmark. 10% to the treasury reserve for audits, integrations, and future opportunities.</a:t>
+            </a:r>
+          </a:p>
+          <a:p/>
+          <a:p>
+            <a:r>
+              <a:t>That's 100%. The DeFi yield — up to 10% of excess reserves deployed to Aave — sits on top of that, not inside it. It improves returns without touching the required allocation buckets.</a:t>
+            </a:r>
+          </a:p>
+        </p:txBody>
+      </p:sp>
+      <p:sp>
+        <p:nvSpPr>
+          <p:cNvPr id="4" name="Slide Number Placeholder 3"/>
+          <p:cNvSpPr>
+            <a:spLocks noGrp="1"/>
+          </p:cNvSpPr>
+          <p:nvPr>
+            <p:ph type="sldNum" idx="5" sz="quarter"/>
+          </p:nvPr>
+        </p:nvSpPr>
+        <p:spPr/>
+      </p:sp>
+    </p:spTree>
+  </p:cSld>
+  <p:clrMapOvr>
+    <a:masterClrMapping/>
+  </p:clrMapOvr>
+</p:notes>
+</file>
+
+<file path=ppt/notesSlides/notesSlide2.xml><?xml version="1.0" encoding="utf-8"?>
+<p:notes xmlns:a="http://schemas.openxmlformats.org/drawingml/2006/main" xmlns:p="http://schemas.openxmlformats.org/presentationml/2006/main" xmlns:r="http://schemas.openxmlformats.org/officeDocument/2006/relationships">
+  <p:cSld>
+    <p:spTree>
+      <p:nvGrpSpPr>
+        <p:cNvPr id="1" name=""/>
+        <p:cNvGrpSpPr/>
+        <p:nvPr/>
+      </p:nvGrpSpPr>
+      <p:grpSpPr>
+        <a:xfrm>
+          <a:off x="0" y="0"/>
+          <a:ext cx="0" cy="0"/>
+          <a:chOff x="0" y="0"/>
+          <a:chExt cx="0" cy="0"/>
+        </a:xfrm>
+      </p:grpSpPr>
+      <p:sp>
+        <p:nvSpPr>
+          <p:cNvPr id="2" name="Slide Image Placeholder 1"/>
+          <p:cNvSpPr>
+            <a:spLocks noGrp="1"/>
+          </p:cNvSpPr>
+          <p:nvPr>
+            <p:ph type="sldImg" idx="2"/>
+          </p:nvPr>
+        </p:nvSpPr>
+        <p:spPr/>
+      </p:sp>
+      <p:sp>
+        <p:nvSpPr>
+          <p:cNvPr id="3" name="Notes Placeholder 2"/>
+          <p:cNvSpPr>
+            <a:spLocks noGrp="1"/>
+          </p:cNvSpPr>
+          <p:nvPr>
+            <p:ph type="body" idx="3" sz="quarter"/>
+          </p:nvPr>
+        </p:nvSpPr>
+        <p:spPr/>
+        <p:txBody>
+          <a:bodyPr/>
+          <a:lstStyle/>
+          <a:p>
+            <a:r>
+              <a:t>The core problem is information asymmetry — and it shows up identically in two markets.</a:t>
+            </a:r>
+          </a:p>
+          <a:p/>
+          <a:p>
+            <a:r>
+              <a:t>In the used-bike market: sellers know everything about a bike's history; buyers can verify almost nothing. Accident records can be hidden, mileage can be rolled back, and maintenance records can be fabricated. This is Akerlof's lemons problem in its most literal form — bad actors drive honest sellers out, prices become inefficient, and trust collapses.</a:t>
+            </a:r>
+          </a:p>
+          <a:p/>
+          <a:p>
+            <a:r>
+              <a:t>In motorcycle insurance: insurers don't have behavioral data, so they price risk using demographics — age, how long you've had your license. This means a 22-year-old who rides carefully subsidizes a 40-year-old who rides recklessly.</a:t>
+            </a:r>
+          </a:p>
+          <a:p/>
+          <a:p>
+            <a:r>
+              <a:t>Both problems trace back to the same root cause: there is no shared, tamper-proof, portable record of what actually happened to a bike or how a rider actually behaves. That's what we're building.</a:t>
+            </a:r>
+          </a:p>
+        </p:txBody>
+      </p:sp>
+      <p:sp>
+        <p:nvSpPr>
+          <p:cNvPr id="4" name="Slide Number Placeholder 3"/>
+          <p:cNvSpPr>
+            <a:spLocks noGrp="1"/>
+          </p:cNvSpPr>
+          <p:nvPr>
+            <p:ph type="sldNum" idx="5" sz="quarter"/>
+          </p:nvPr>
+        </p:nvSpPr>
+        <p:spPr/>
+      </p:sp>
+    </p:spTree>
+  </p:cSld>
+  <p:clrMapOvr>
+    <a:masterClrMapping/>
+  </p:clrMapOvr>
+</p:notes>
+</file>
+
+<file path=ppt/notesSlides/notesSlide20.xml><?xml version="1.0" encoding="utf-8"?>
+<p:notes xmlns:a="http://schemas.openxmlformats.org/drawingml/2006/main" xmlns:p="http://schemas.openxmlformats.org/presentationml/2006/main" xmlns:r="http://schemas.openxmlformats.org/officeDocument/2006/relationships">
+  <p:cSld>
+    <p:spTree>
+      <p:nvGrpSpPr>
+        <p:cNvPr id="1" name=""/>
+        <p:cNvGrpSpPr/>
+        <p:nvPr/>
+      </p:nvGrpSpPr>
+      <p:grpSpPr>
+        <a:xfrm>
+          <a:off x="0" y="0"/>
+          <a:ext cx="0" cy="0"/>
+          <a:chOff x="0" y="0"/>
+          <a:chExt cx="0" cy="0"/>
+        </a:xfrm>
+      </p:grpSpPr>
+      <p:sp>
+        <p:nvSpPr>
+          <p:cNvPr id="2" name="Slide Image Placeholder 1"/>
+          <p:cNvSpPr>
+            <a:spLocks noGrp="1"/>
+          </p:cNvSpPr>
+          <p:nvPr>
+            <p:ph type="sldImg" idx="2"/>
+          </p:nvPr>
+        </p:nvSpPr>
+        <p:spPr/>
+      </p:sp>
+      <p:sp>
+        <p:nvSpPr>
+          <p:cNvPr id="3" name="Notes Placeholder 2"/>
+          <p:cNvSpPr>
+            <a:spLocks noGrp="1"/>
+          </p:cNvSpPr>
+          <p:nvPr>
+            <p:ph type="body" idx="3" sz="quarter"/>
+          </p:nvPr>
+        </p:nvSpPr>
+        <p:spPr/>
+        <p:txBody>
+          <a:bodyPr/>
+          <a:lstStyle/>
+          <a:p>
+            <a:r>
+              <a:t>Every model has breaking points. We think naming them explicitly is more credible than pretending they don't exist.</a:t>
+            </a:r>
+          </a:p>
+          <a:p/>
+          <a:p>
+            <a:r>
+              <a:t>Two critical risks: if we get fewer than 1,500 active riders in Year 1, revenue can't cover engineering and operations — runway drops to about 6 months. And if LP capital comes in below 50% of target, the pool runs thin and we either shrink coverage limits or pause new rider enrollment.</a:t>
+            </a:r>
+          </a:p>
+          <a:p/>
+          <a:p>
+            <a:r>
+              <a:t>Two high-severity risks: if more than 25% of riders file claims per year, the loss ratio jumps above 60% and we have to cut rebates and raise premiums. If average claims exceed 4 million won, the loss ratio approaches 75% and the LP backstop absorbs the gap.</a:t>
+            </a:r>
+          </a:p>
+          <a:p/>
+          <a:p>
+            <a:r>
+              <a:t>Two medium risks: no B2B partners by Year 2 means our largest projected revenue stream collapses and profitability slips to Year 4. A single catastrophic event above 1 billion won in one week triggers emergency mode — staged payouts, reinsurance call, catastrophe reserve drain.</a:t>
+            </a:r>
+          </a:p>
+          <a:p/>
+          <a:p>
+            <a:r>
+              <a:t>Each of these has a specific mitigation. The point of this slide is that we've modeled the failures, not just the successes.</a:t>
+            </a:r>
+          </a:p>
+        </p:txBody>
+      </p:sp>
+      <p:sp>
+        <p:nvSpPr>
+          <p:cNvPr id="4" name="Slide Number Placeholder 3"/>
+          <p:cNvSpPr>
+            <a:spLocks noGrp="1"/>
+          </p:cNvSpPr>
+          <p:nvPr>
+            <p:ph type="sldNum" idx="5" sz="quarter"/>
+          </p:nvPr>
+        </p:nvSpPr>
+        <p:spPr/>
+      </p:sp>
+    </p:spTree>
+  </p:cSld>
+  <p:clrMapOvr>
+    <a:masterClrMapping/>
+  </p:clrMapOvr>
+</p:notes>
+</file>
+
+<file path=ppt/notesSlides/notesSlide21.xml><?xml version="1.0" encoding="utf-8"?>
+<p:notes xmlns:a="http://schemas.openxmlformats.org/drawingml/2006/main" xmlns:p="http://schemas.openxmlformats.org/presentationml/2006/main" xmlns:r="http://schemas.openxmlformats.org/officeDocument/2006/relationships">
+  <p:cSld>
+    <p:spTree>
+      <p:nvGrpSpPr>
+        <p:cNvPr id="1" name=""/>
+        <p:cNvGrpSpPr/>
+        <p:nvPr/>
+      </p:nvGrpSpPr>
+      <p:grpSpPr>
+        <a:xfrm>
+          <a:off x="0" y="0"/>
+          <a:ext cx="0" cy="0"/>
+          <a:chOff x="0" y="0"/>
+          <a:chExt cx="0" cy="0"/>
+        </a:xfrm>
+      </p:grpSpPr>
+      <p:sp>
+        <p:nvSpPr>
+          <p:cNvPr id="2" name="Slide Image Placeholder 1"/>
+          <p:cNvSpPr>
+            <a:spLocks noGrp="1"/>
+          </p:cNvSpPr>
+          <p:nvPr>
+            <p:ph type="sldImg" idx="2"/>
+          </p:nvPr>
+        </p:nvSpPr>
+        <p:spPr/>
+      </p:sp>
+      <p:sp>
+        <p:nvSpPr>
+          <p:cNvPr id="3" name="Notes Placeholder 2"/>
+          <p:cNvSpPr>
+            <a:spLocks noGrp="1"/>
+          </p:cNvSpPr>
+          <p:nvPr>
+            <p:ph type="body" idx="3" sz="quarter"/>
+          </p:nvPr>
+        </p:nvSpPr>
+        <p:spPr/>
+        <p:txBody>
+          <a:bodyPr/>
+          <a:lstStyle/>
+          <a:p>
+            <a:r>
+              <a:t>Three competitor types, and we're not trying to beat any of them head-on.</a:t>
+            </a:r>
+          </a:p>
+          <a:p/>
+          <a:p>
+            <a:r>
+              <a:t>Centralized history providers like CARFAX own the data — you can't take your history with you, and there's no real penalty for fake records. Our edge: records are user-owned, economically staked, and fraud is automatically slashed.</a:t>
+            </a:r>
+          </a:p>
+          <a:p/>
+          <a:p>
+            <a:r>
+              <a:t>Traditional Korean insurers like Samsung Fire and Marine price behavior using demographics because they don't have behavioral data. Our edge: behavior score follows the rider across providers, claims settle on-chain in days, not weeks.</a:t>
+            </a:r>
+          </a:p>
+          <a:p/>
+          <a:p>
+            <a:r>
+              <a:t>DeFi insurance protocols like Nexus Mutual are built for smart contract risk — they have no real-world data moat and almost no consumer reach. Our edge: real motorcycle data, identity plus behavior in one stack, and consumer-grade UX via account abstraction.</a:t>
+            </a:r>
+          </a:p>
+          <a:p/>
+          <a:p>
+            <a:r>
+              <a:t>Our moat is the vertical data network effect. Every new bike, rider, mechanic, dealer, and partner makes the dataset more valuable and harder to replicate. We own the intersection that none of our competitors can occupy alone.</a:t>
+            </a:r>
+          </a:p>
+        </p:txBody>
+      </p:sp>
+      <p:sp>
+        <p:nvSpPr>
+          <p:cNvPr id="4" name="Slide Number Placeholder 3"/>
+          <p:cNvSpPr>
+            <a:spLocks noGrp="1"/>
+          </p:cNvSpPr>
+          <p:nvPr>
+            <p:ph type="sldNum" idx="5" sz="quarter"/>
+          </p:nvPr>
+        </p:nvSpPr>
+        <p:spPr/>
+      </p:sp>
+    </p:spTree>
+  </p:cSld>
+  <p:clrMapOvr>
+    <a:masterClrMapping/>
+  </p:clrMapOvr>
+</p:notes>
+</file>
+
+<file path=ppt/notesSlides/notesSlide22.xml><?xml version="1.0" encoding="utf-8"?>
+<p:notes xmlns:a="http://schemas.openxmlformats.org/drawingml/2006/main" xmlns:p="http://schemas.openxmlformats.org/presentationml/2006/main" xmlns:r="http://schemas.openxmlformats.org/officeDocument/2006/relationships">
+  <p:cSld>
+    <p:spTree>
+      <p:nvGrpSpPr>
+        <p:cNvPr id="1" name=""/>
+        <p:cNvGrpSpPr/>
+        <p:nvPr/>
+      </p:nvGrpSpPr>
+      <p:grpSpPr>
+        <a:xfrm>
+          <a:off x="0" y="0"/>
+          <a:ext cx="0" cy="0"/>
+          <a:chOff x="0" y="0"/>
+          <a:chExt cx="0" cy="0"/>
+        </a:xfrm>
+      </p:grpSpPr>
+      <p:sp>
+        <p:nvSpPr>
+          <p:cNvPr id="2" name="Slide Image Placeholder 1"/>
+          <p:cNvSpPr>
+            <a:spLocks noGrp="1"/>
+          </p:cNvSpPr>
+          <p:nvPr>
+            <p:ph type="sldImg" idx="2"/>
+          </p:nvPr>
+        </p:nvSpPr>
+        <p:spPr/>
+      </p:sp>
+      <p:sp>
+        <p:nvSpPr>
+          <p:cNvPr id="3" name="Notes Placeholder 2"/>
+          <p:cNvSpPr>
+            <a:spLocks noGrp="1"/>
+          </p:cNvSpPr>
+          <p:nvPr>
+            <p:ph type="body" idx="3" sz="quarter"/>
+          </p:nvPr>
+        </p:nvSpPr>
+        <p:spPr/>
+        <p:txBody>
+          <a:bodyPr/>
+          <a:lstStyle/>
+          <a:p>
+            <a:r>
+              <a:t>Security isn't a one-time event — it's a continuous practice. Our roadmap has five waypoints.</a:t>
+            </a:r>
+          </a:p>
+          <a:p/>
+          <a:p>
+            <a:r>
+              <a:t>Pre-launch internal: we test like adversaries. Full coverage on every contract function that touches money. Fuzz testing and invariant testing to break our own code before anyone else does.</a:t>
+            </a:r>
+          </a:p>
+          <a:p/>
+          <a:p>
+            <a:r>
+              <a:t>Pre-launch external: two independent audit firms — we're targeting OpenZeppelin and Trail of Bits. Every finding published in full.</a:t>
+            </a:r>
+          </a:p>
+          <a:p/>
+          <a:p>
+            <a:r>
+              <a:t>Day 0 on mainnet: 5-of-9 multisig on treasury, 48-hour timelock on upgrades, emergency pause narrowly scoped to a security council.</a:t>
+            </a:r>
+          </a:p>
+          <a:p/>
+          <a:p>
+            <a:r>
+              <a:t>Post-launch forever: a live bug bounty on Immunefi — up to 250,000 dollars for critical findings, 75,000 for high, 15,000 for medium.</a:t>
+            </a:r>
+          </a:p>
+          <a:p/>
+          <a:p>
+            <a:r>
+              <a:t>Continuous: audit every major upgrade, annual penetration tests, public incident playbook, quarterly drills.</a:t>
+            </a:r>
+          </a:p>
+          <a:p/>
+          <a:p>
+            <a:r>
+              <a:t>Security is one of our key credibility markers with institutional partners and LP capital. We treat it accordingly.</a:t>
+            </a:r>
+          </a:p>
+        </p:txBody>
+      </p:sp>
+      <p:sp>
+        <p:nvSpPr>
+          <p:cNvPr id="4" name="Slide Number Placeholder 3"/>
+          <p:cNvSpPr>
+            <a:spLocks noGrp="1"/>
+          </p:cNvSpPr>
+          <p:nvPr>
+            <p:ph type="sldNum" idx="5" sz="quarter"/>
+          </p:nvPr>
+        </p:nvSpPr>
+        <p:spPr/>
+      </p:sp>
+    </p:spTree>
+  </p:cSld>
+  <p:clrMapOvr>
+    <a:masterClrMapping/>
+  </p:clrMapOvr>
+</p:notes>
+</file>
+
+<file path=ppt/notesSlides/notesSlide23.xml><?xml version="1.0" encoding="utf-8"?>
+<p:notes xmlns:a="http://schemas.openxmlformats.org/drawingml/2006/main" xmlns:p="http://schemas.openxmlformats.org/presentationml/2006/main" xmlns:r="http://schemas.openxmlformats.org/officeDocument/2006/relationships">
+  <p:cSld>
+    <p:spTree>
+      <p:nvGrpSpPr>
+        <p:cNvPr id="1" name=""/>
+        <p:cNvGrpSpPr/>
+        <p:nvPr/>
+      </p:nvGrpSpPr>
+      <p:grpSpPr>
+        <a:xfrm>
+          <a:off x="0" y="0"/>
+          <a:ext cx="0" cy="0"/>
+          <a:chOff x="0" y="0"/>
+          <a:chExt cx="0" cy="0"/>
+        </a:xfrm>
+      </p:grpSpPr>
+      <p:sp>
+        <p:nvSpPr>
+          <p:cNvPr id="2" name="Slide Image Placeholder 1"/>
+          <p:cNvSpPr>
+            <a:spLocks noGrp="1"/>
+          </p:cNvSpPr>
+          <p:nvPr>
+            <p:ph type="sldImg" idx="2"/>
+          </p:nvPr>
+        </p:nvSpPr>
+        <p:spPr/>
+      </p:sp>
+      <p:sp>
+        <p:nvSpPr>
+          <p:cNvPr id="3" name="Notes Placeholder 2"/>
+          <p:cNvSpPr>
+            <a:spLocks noGrp="1"/>
+          </p:cNvSpPr>
+          <p:nvPr>
+            <p:ph type="body" idx="3" sz="quarter"/>
+          </p:nvPr>
+        </p:nvSpPr>
+        <p:spPr/>
+        <p:txBody>
+          <a:bodyPr/>
+          <a:lstStyle/>
+          <a:p>
+            <a:r>
+              <a:t>Seven layers of liquidity defense — the goal is simple: money is always available when a rider needs it.</a:t>
+            </a:r>
+          </a:p>
+          <a:p/>
+          <a:p>
+            <a:r>
+              <a:t>25% liquid reserve floor, always in USDC, never deployed. Only 10 to 15% of excess reserves can earn yield. Large LP redemptions above 5% of the pool require 30 days notice to prevent bank-run dynamics. In emergency mode, withdrawals queue pro-rata — first in line doesn't mean first served.</a:t>
+            </a:r>
+          </a:p>
+          <a:p/>
+          <a:p>
+            <a:r>
+              <a:t>External reinsurance backstop for tail risk above pool capacity. Capital held across at least two regulated stablecoin issuers — no single-stablecoin dependency. And all of this is visible on a public real-time dashboard: pool reserves, deployment ratios, claim queue, exit queue.</a:t>
+            </a:r>
+          </a:p>
+          <a:p/>
+          <a:p>
+            <a:r>
+              <a:t>The promise: approved claims pay under normal conditions; in stress, LPs and riders are protected proportionally and transparently.</a:t>
+            </a:r>
+          </a:p>
+        </p:txBody>
+      </p:sp>
+      <p:sp>
+        <p:nvSpPr>
+          <p:cNvPr id="4" name="Slide Number Placeholder 3"/>
+          <p:cNvSpPr>
+            <a:spLocks noGrp="1"/>
+          </p:cNvSpPr>
+          <p:nvPr>
+            <p:ph type="sldNum" idx="5" sz="quarter"/>
+          </p:nvPr>
+        </p:nvSpPr>
+        <p:spPr/>
+      </p:sp>
+    </p:spTree>
+  </p:cSld>
+  <p:clrMapOvr>
+    <a:masterClrMapping/>
+  </p:clrMapOvr>
+</p:notes>
+</file>
+
+<file path=ppt/notesSlides/notesSlide24.xml><?xml version="1.0" encoding="utf-8"?>
+<p:notes xmlns:a="http://schemas.openxmlformats.org/drawingml/2006/main" xmlns:p="http://schemas.openxmlformats.org/presentationml/2006/main" xmlns:r="http://schemas.openxmlformats.org/officeDocument/2006/relationships">
+  <p:cSld>
+    <p:spTree>
+      <p:nvGrpSpPr>
+        <p:cNvPr id="1" name=""/>
+        <p:cNvGrpSpPr/>
+        <p:nvPr/>
+      </p:nvGrpSpPr>
+      <p:grpSpPr>
+        <a:xfrm>
+          <a:off x="0" y="0"/>
+          <a:ext cx="0" cy="0"/>
+          <a:chOff x="0" y="0"/>
+          <a:chExt cx="0" cy="0"/>
+        </a:xfrm>
+      </p:grpSpPr>
+      <p:sp>
+        <p:nvSpPr>
+          <p:cNvPr id="2" name="Slide Image Placeholder 1"/>
+          <p:cNvSpPr>
+            <a:spLocks noGrp="1"/>
+          </p:cNvSpPr>
+          <p:nvPr>
+            <p:ph type="sldImg" idx="2"/>
+          </p:nvPr>
+        </p:nvSpPr>
+        <p:spPr/>
+      </p:sp>
+      <p:sp>
+        <p:nvSpPr>
+          <p:cNvPr id="3" name="Notes Placeholder 2"/>
+          <p:cNvSpPr>
+            <a:spLocks noGrp="1"/>
+          </p:cNvSpPr>
+          <p:nvPr>
+            <p:ph type="body" idx="3" sz="quarter"/>
+          </p:nvPr>
+        </p:nvSpPr>
+        <p:spPr/>
+        <p:txBody>
+          <a:bodyPr/>
+          <a:lstStyle/>
+          <a:p>
+            <a:r>
+              <a:t>The oracle layer is how off-chain truth enters the on-chain system. Our four defenses around every data point:</a:t>
+            </a:r>
+          </a:p>
+          <a:p/>
+          <a:p>
+            <a:r>
+              <a:t>Multi-source verification: claims require police records, repair-shop confirmation, AND insurer data. No single source decides anything. Staking and slashing: oracle providers post collateral on their data feeds — bad data costs them. Tiered consensus: large claims require a higher quorum and longer review window; small claims clear fast. Auto-pause on conflict: if feeds go stale or disagree, contracts halt automatically and disputes escalate to arbitration.</a:t>
+            </a:r>
+          </a:p>
+          <a:p/>
+          <a:p>
+            <a:r>
+              <a:t>We aggregate from Chainlink-style decentralized feeds plus protocol-specific sources. No single data provider is ever the deciding vote.</a:t>
+            </a:r>
+          </a:p>
+        </p:txBody>
+      </p:sp>
+      <p:sp>
+        <p:nvSpPr>
+          <p:cNvPr id="4" name="Slide Number Placeholder 3"/>
+          <p:cNvSpPr>
+            <a:spLocks noGrp="1"/>
+          </p:cNvSpPr>
+          <p:nvPr>
+            <p:ph type="sldNum" idx="5" sz="quarter"/>
+          </p:nvPr>
+        </p:nvSpPr>
+        <p:spPr/>
+      </p:sp>
+    </p:spTree>
+  </p:cSld>
+  <p:clrMapOvr>
+    <a:masterClrMapping/>
+  </p:clrMapOvr>
+</p:notes>
+</file>
+
+<file path=ppt/notesSlides/notesSlide25.xml><?xml version="1.0" encoding="utf-8"?>
+<p:notes xmlns:a="http://schemas.openxmlformats.org/drawingml/2006/main" xmlns:p="http://schemas.openxmlformats.org/presentationml/2006/main" xmlns:r="http://schemas.openxmlformats.org/officeDocument/2006/relationships">
+  <p:cSld>
+    <p:spTree>
+      <p:nvGrpSpPr>
+        <p:cNvPr id="1" name=""/>
+        <p:cNvGrpSpPr/>
+        <p:nvPr/>
+      </p:nvGrpSpPr>
+      <p:grpSpPr>
+        <a:xfrm>
+          <a:off x="0" y="0"/>
+          <a:ext cx="0" cy="0"/>
+          <a:chOff x="0" y="0"/>
+          <a:chExt cx="0" cy="0"/>
+        </a:xfrm>
+      </p:grpSpPr>
+      <p:sp>
+        <p:nvSpPr>
+          <p:cNvPr id="2" name="Slide Image Placeholder 1"/>
+          <p:cNvSpPr>
+            <a:spLocks noGrp="1"/>
+          </p:cNvSpPr>
+          <p:nvPr>
+            <p:ph type="sldImg" idx="2"/>
+          </p:nvPr>
+        </p:nvSpPr>
+        <p:spPr/>
+      </p:sp>
+      <p:sp>
+        <p:nvSpPr>
+          <p:cNvPr id="3" name="Notes Placeholder 2"/>
+          <p:cNvSpPr>
+            <a:spLocks noGrp="1"/>
+          </p:cNvSpPr>
+          <p:nvPr>
+            <p:ph type="body" idx="3" sz="quarter"/>
+          </p:nvPr>
+        </p:nvSpPr>
+        <p:spPr/>
+        <p:txBody>
+          <a:bodyPr/>
+          <a:lstStyle/>
+          <a:p>
+            <a:r>
+              <a:t>The final slide addresses mechanic trust — and this is one of the places where the design is most carefully layered.</a:t>
+            </a:r>
+          </a:p>
+          <a:p/>
+          <a:p>
+            <a:r>
+              <a:t>Prevention: every service entry requires sign-off from both the mechanic and the bike owner. Neither party can fake a repair the other didn't agree to. Hardware reads mileage directly from the bike, so odometer fraud is blocked at the source.</a:t>
+            </a:r>
+          </a:p>
+          <a:p/>
+          <a:p>
+            <a:r>
+              <a:t>Detection: we have an open bounty system — anyone who spots and proves a fake record earns a share of the cheater's staked collateral. The community becomes the watchdog. And at every moment of financial consequence — sale, financing, insurance — we re-verify the history. Fraud gets caught exactly when it would pay off.</a:t>
+            </a:r>
+          </a:p>
+          <a:p/>
+          <a:p>
+            <a:r>
+              <a:t>Enforcement: reputation and reward scale together. Mechanics start with small stakes and grow over time. Fees sit in escrow for 30 to 90 days — disputes claw them back. And each entry locks a slice of stake, so high-volume fraudsters have the most to lose.</a:t>
+            </a:r>
+          </a:p>
+          <a:p/>
+          <a:p>
+            <a:r>
+              <a:t>The design principle: none of these layers works alone, but together they make fraud unprofitable.</a:t>
+            </a:r>
+          </a:p>
+          <a:p/>
+          <a:p>
+            <a:r>
+              <a:t>That wraps our interim report. We're happy to take questions on any section.</a:t>
+            </a:r>
+          </a:p>
+        </p:txBody>
+      </p:sp>
+      <p:sp>
+        <p:nvSpPr>
+          <p:cNvPr id="4" name="Slide Number Placeholder 3"/>
+          <p:cNvSpPr>
+            <a:spLocks noGrp="1"/>
+          </p:cNvSpPr>
+          <p:nvPr>
+            <p:ph type="sldNum" idx="5" sz="quarter"/>
+          </p:nvPr>
+        </p:nvSpPr>
+        <p:spPr/>
+      </p:sp>
+    </p:spTree>
+  </p:cSld>
+  <p:clrMapOvr>
+    <a:masterClrMapping/>
+  </p:clrMapOvr>
+</p:notes>
+</file>
+
+<file path=ppt/notesSlides/notesSlide3.xml><?xml version="1.0" encoding="utf-8"?>
+<p:notes xmlns:a="http://schemas.openxmlformats.org/drawingml/2006/main" xmlns:p="http://schemas.openxmlformats.org/presentationml/2006/main" xmlns:r="http://schemas.openxmlformats.org/officeDocument/2006/relationships">
+  <p:cSld>
+    <p:spTree>
+      <p:nvGrpSpPr>
+        <p:cNvPr id="1" name=""/>
+        <p:cNvGrpSpPr/>
+        <p:nvPr/>
+      </p:nvGrpSpPr>
+      <p:grpSpPr>
+        <a:xfrm>
+          <a:off x="0" y="0"/>
+          <a:ext cx="0" cy="0"/>
+          <a:chOff x="0" y="0"/>
+          <a:chExt cx="0" cy="0"/>
+        </a:xfrm>
+      </p:grpSpPr>
+      <p:sp>
+        <p:nvSpPr>
+          <p:cNvPr id="2" name="Slide Image Placeholder 1"/>
+          <p:cNvSpPr>
+            <a:spLocks noGrp="1"/>
+          </p:cNvSpPr>
+          <p:nvPr>
+            <p:ph type="sldImg" idx="2"/>
+          </p:nvPr>
+        </p:nvSpPr>
+        <p:spPr/>
+      </p:sp>
+      <p:sp>
+        <p:nvSpPr>
+          <p:cNvPr id="3" name="Notes Placeholder 2"/>
+          <p:cNvSpPr>
+            <a:spLocks noGrp="1"/>
+          </p:cNvSpPr>
+          <p:nvPr>
+            <p:ph type="body" idx="3" sz="quarter"/>
+          </p:nvPr>
+        </p:nvSpPr>
+        <p:spPr/>
+        <p:txBody>
+          <a:bodyPr/>
+          <a:lstStyle/>
+          <a:p>
+            <a:r>
+              <a:t>So here's our one-paragraph pitch: MotoChain and RideTrue replace trust-based inefficiency with verifiable, user-owned data.</a:t>
+            </a:r>
+          </a:p>
+          <a:p/>
+          <a:p>
+            <a:r>
+              <a:t>MotoChain anchors each motorcycle to a permanent on-chain identity tied to its VIN. Every service record, ownership transfer, and mileage reading is cryptographically signed and immutable.</a:t>
+            </a:r>
+          </a:p>
+          <a:p/>
+          <a:p>
+            <a:r>
+              <a:t>RideTrue takes that foundation and layers a behavior-based insurance pool on top. Instead of pricing riders by demographic proxies, we price them by how they actually ride — captured via telematics and verified using zero-knowledge proofs.</a:t>
+            </a:r>
+          </a:p>
+          <a:p/>
+          <a:p>
+            <a:r>
+              <a:t>Our mission is simple: verifiable identity for the bike, verifiable behavior for the rider. Both on-chain, both owned by the user — not by an insurer or a platform.</a:t>
+            </a:r>
+          </a:p>
+        </p:txBody>
+      </p:sp>
+      <p:sp>
+        <p:nvSpPr>
+          <p:cNvPr id="4" name="Slide Number Placeholder 3"/>
+          <p:cNvSpPr>
+            <a:spLocks noGrp="1"/>
+          </p:cNvSpPr>
+          <p:nvPr>
+            <p:ph type="sldNum" idx="5" sz="quarter"/>
+          </p:nvPr>
+        </p:nvSpPr>
+        <p:spPr/>
+      </p:sp>
+    </p:spTree>
+  </p:cSld>
+  <p:clrMapOvr>
+    <a:masterClrMapping/>
+  </p:clrMapOvr>
+</p:notes>
+</file>
+
+<file path=ppt/notesSlides/notesSlide4.xml><?xml version="1.0" encoding="utf-8"?>
+<p:notes xmlns:a="http://schemas.openxmlformats.org/drawingml/2006/main" xmlns:p="http://schemas.openxmlformats.org/presentationml/2006/main" xmlns:r="http://schemas.openxmlformats.org/officeDocument/2006/relationships">
+  <p:cSld>
+    <p:spTree>
+      <p:nvGrpSpPr>
+        <p:cNvPr id="1" name=""/>
+        <p:cNvGrpSpPr/>
+        <p:nvPr/>
+      </p:nvGrpSpPr>
+      <p:grpSpPr>
+        <a:xfrm>
+          <a:off x="0" y="0"/>
+          <a:ext cx="0" cy="0"/>
+          <a:chOff x="0" y="0"/>
+          <a:chExt cx="0" cy="0"/>
+        </a:xfrm>
+      </p:grpSpPr>
+      <p:sp>
+        <p:nvSpPr>
+          <p:cNvPr id="2" name="Slide Image Placeholder 1"/>
+          <p:cNvSpPr>
+            <a:spLocks noGrp="1"/>
+          </p:cNvSpPr>
+          <p:nvPr>
+            <p:ph type="sldImg" idx="2"/>
+          </p:nvPr>
+        </p:nvSpPr>
+        <p:spPr/>
+      </p:sp>
+      <p:sp>
+        <p:nvSpPr>
+          <p:cNvPr id="3" name="Notes Placeholder 2"/>
+          <p:cNvSpPr>
+            <a:spLocks noGrp="1"/>
+          </p:cNvSpPr>
+          <p:nvPr>
+            <p:ph type="body" idx="3" sz="quarter"/>
+          </p:nvPr>
+        </p:nvSpPr>
+        <p:spPr/>
+        <p:txBody>
+          <a:bodyPr/>
+          <a:lstStyle/>
+          <a:p>
+            <a:r>
+              <a:t>Let's ground this in market size. The global motorcycle market is over 120 billion dollars annually. The global motorcycle insurance market is over 70 billion. Combined, that's a 190 billion dollar problem space.</a:t>
+            </a:r>
+          </a:p>
+          <a:p/>
+          <a:p>
+            <a:r>
+              <a:t>And these aren't just big numbers — there's recoverable value here. Industry estimates suggest 5 to 10 percent of transaction value in used-bike markets is lost to fraud and misrepresentation. On the insurance side, even a 1 to 2 percent improvement in pricing accuracy translates to billions of dollars in recoverable value.</a:t>
+            </a:r>
+          </a:p>
+          <a:p/>
+          <a:p>
+            <a:r>
+              <a:t>Now, why blockchain specifically? Not because it's a trend — because it's the only structure that delivers four things simultaneously: immutable records, decentralized validation, economic enforcement, and portable identity. Centralized alternatives fail because any single institution controlling the data has a conflict of interest, and competitors won't share. Blockchain removes that intermediary entirely.</a:t>
+            </a:r>
+          </a:p>
+        </p:txBody>
+      </p:sp>
+      <p:sp>
+        <p:nvSpPr>
+          <p:cNvPr id="4" name="Slide Number Placeholder 3"/>
+          <p:cNvSpPr>
+            <a:spLocks noGrp="1"/>
+          </p:cNvSpPr>
+          <p:nvPr>
+            <p:ph type="sldNum" idx="5" sz="quarter"/>
+          </p:nvPr>
+        </p:nvSpPr>
+        <p:spPr/>
+      </p:sp>
+    </p:spTree>
+  </p:cSld>
+  <p:clrMapOvr>
+    <a:masterClrMapping/>
+  </p:clrMapOvr>
+</p:notes>
+</file>
+
+<file path=ppt/notesSlides/notesSlide5.xml><?xml version="1.0" encoding="utf-8"?>
+<p:notes xmlns:a="http://schemas.openxmlformats.org/drawingml/2006/main" xmlns:p="http://schemas.openxmlformats.org/presentationml/2006/main" xmlns:r="http://schemas.openxmlformats.org/officeDocument/2006/relationships">
+  <p:cSld>
+    <p:spTree>
+      <p:nvGrpSpPr>
+        <p:cNvPr id="1" name=""/>
+        <p:cNvGrpSpPr/>
+        <p:nvPr/>
+      </p:nvGrpSpPr>
+      <p:grpSpPr>
+        <a:xfrm>
+          <a:off x="0" y="0"/>
+          <a:ext cx="0" cy="0"/>
+          <a:chOff x="0" y="0"/>
+          <a:chExt cx="0" cy="0"/>
+        </a:xfrm>
+      </p:grpSpPr>
+      <p:sp>
+        <p:nvSpPr>
+          <p:cNvPr id="2" name="Slide Image Placeholder 1"/>
+          <p:cNvSpPr>
+            <a:spLocks noGrp="1"/>
+          </p:cNvSpPr>
+          <p:nvPr>
+            <p:ph type="sldImg" idx="2"/>
+          </p:nvPr>
+        </p:nvSpPr>
+        <p:spPr/>
+      </p:sp>
+      <p:sp>
+        <p:nvSpPr>
+          <p:cNvPr id="3" name="Notes Placeholder 2"/>
+          <p:cNvSpPr>
+            <a:spLocks noGrp="1"/>
+          </p:cNvSpPr>
+          <p:nvPr>
+            <p:ph type="body" idx="3" sz="quarter"/>
+          </p:nvPr>
+        </p:nvSpPr>
+        <p:spPr/>
+        <p:txBody>
+          <a:bodyPr/>
+          <a:lstStyle/>
+          <a:p>
+            <a:r>
+              <a:t>Our technical architecture is two contracts on one chain — Base, which is an Ethereum Layer 2.</a:t>
+            </a:r>
+          </a:p>
+          <a:p/>
+          <a:p>
+            <a:r>
+              <a:t>Protocol A is MotoChain: the motorcycle identity and history registry. It manages VIN-linked identity tokens, controlled ownership transfers, staked service entries from authorized mechanics, and protocol-level integrity rules that automatically flag non-sequential mileage.</a:t>
+            </a:r>
+          </a:p>
+          <a:p/>
+          <a:p>
+            <a:r>
+              <a:t>Protocol B is RideTrue: the behavior-based rider insurance pool. It manages rider identity and safety scores updated from off-chain telematics, ZK-proof attestations that verify safe behavior without exposing raw GPS data, a USDC insurance pool, and DeFi composability — idle capital gets deployed into Aave for yield.</a:t>
+            </a:r>
+          </a:p>
+          <a:p/>
+          <a:p>
+            <a:r>
+              <a:t>We chose Base because it gives us sub-5-cent transactions, Ethereum's security guarantees, and fast finality — which we need for frequent service records and real-time behavioral scoring.</a:t>
+            </a:r>
+          </a:p>
+        </p:txBody>
+      </p:sp>
+      <p:sp>
+        <p:nvSpPr>
+          <p:cNvPr id="4" name="Slide Number Placeholder 3"/>
+          <p:cNvSpPr>
+            <a:spLocks noGrp="1"/>
+          </p:cNvSpPr>
+          <p:nvPr>
+            <p:ph type="sldNum" idx="5" sz="quarter"/>
+          </p:nvPr>
+        </p:nvSpPr>
+        <p:spPr/>
+      </p:sp>
+    </p:spTree>
+  </p:cSld>
+  <p:clrMapOvr>
+    <a:masterClrMapping/>
+  </p:clrMapOvr>
+</p:notes>
+</file>
+
+<file path=ppt/notesSlides/notesSlide6.xml><?xml version="1.0" encoding="utf-8"?>
+<p:notes xmlns:a="http://schemas.openxmlformats.org/drawingml/2006/main" xmlns:p="http://schemas.openxmlformats.org/presentationml/2006/main" xmlns:r="http://schemas.openxmlformats.org/officeDocument/2006/relationships">
+  <p:cSld>
+    <p:spTree>
+      <p:nvGrpSpPr>
+        <p:cNvPr id="1" name=""/>
+        <p:cNvGrpSpPr/>
+        <p:nvPr/>
+      </p:nvGrpSpPr>
+      <p:grpSpPr>
+        <a:xfrm>
+          <a:off x="0" y="0"/>
+          <a:ext cx="0" cy="0"/>
+          <a:chOff x="0" y="0"/>
+          <a:chExt cx="0" cy="0"/>
+        </a:xfrm>
+      </p:grpSpPr>
+      <p:sp>
+        <p:nvSpPr>
+          <p:cNvPr id="2" name="Slide Image Placeholder 1"/>
+          <p:cNvSpPr>
+            <a:spLocks noGrp="1"/>
+          </p:cNvSpPr>
+          <p:nvPr>
+            <p:ph type="sldImg" idx="2"/>
+          </p:nvPr>
+        </p:nvSpPr>
+        <p:spPr/>
+      </p:sp>
+      <p:sp>
+        <p:nvSpPr>
+          <p:cNvPr id="3" name="Notes Placeholder 2"/>
+          <p:cNvSpPr>
+            <a:spLocks noGrp="1"/>
+          </p:cNvSpPr>
+          <p:nvPr>
+            <p:ph type="body" idx="3" sz="quarter"/>
+          </p:nvPr>
+        </p:nvSpPr>
+        <p:spPr/>
+        <p:txBody>
+          <a:bodyPr/>
+          <a:lstStyle/>
+          <a:p>
+            <a:r>
+              <a:t>Let me walk through how MotoChain actually works in practice.</a:t>
+            </a:r>
+          </a:p>
+          <a:p/>
+          <a:p>
+            <a:r>
+              <a:t>A bike enters the system when its VIN is minted as an identity token — a one-time fee, permanent anchor. When the bike changes hands, ownership transfers wallet-to-wallet; the wallet is the title.</a:t>
+            </a:r>
+          </a:p>
+          <a:p/>
+          <a:p>
+            <a:r>
+              <a:t>Service records are written by authorized mechanics who stake collateral before they can write. That stake is at risk if fraud is detected. And the protocol enforces consistency automatically: if a mechanic tries to log a lower mileage than the previous reading, the entry is rejected before it even writes. You can't roll back an odometer at the smart contract level.</a:t>
+            </a:r>
+          </a:p>
+          <a:p/>
+          <a:p>
+            <a:r>
+              <a:t>Two mechanics logging conflicting work on the same bike triggers a dispute window — neither entry finalizes until it resolves. And only wallets with active stake can write at all. Bad data can't be written; it's not just challenged after the fact.</a:t>
+            </a:r>
+          </a:p>
+        </p:txBody>
+      </p:sp>
+      <p:sp>
+        <p:nvSpPr>
+          <p:cNvPr id="4" name="Slide Number Placeholder 3"/>
+          <p:cNvSpPr>
+            <a:spLocks noGrp="1"/>
+          </p:cNvSpPr>
+          <p:nvPr>
+            <p:ph type="sldNum" idx="5" sz="quarter"/>
+          </p:nvPr>
+        </p:nvSpPr>
+        <p:spPr/>
+      </p:sp>
+    </p:spTree>
+  </p:cSld>
+  <p:clrMapOvr>
+    <a:masterClrMapping/>
+  </p:clrMapOvr>
+</p:notes>
+</file>
+
+<file path=ppt/notesSlides/notesSlide7.xml><?xml version="1.0" encoding="utf-8"?>
+<p:notes xmlns:a="http://schemas.openxmlformats.org/drawingml/2006/main" xmlns:p="http://schemas.openxmlformats.org/presentationml/2006/main" xmlns:r="http://schemas.openxmlformats.org/officeDocument/2006/relationships">
+  <p:cSld>
+    <p:spTree>
+      <p:nvGrpSpPr>
+        <p:cNvPr id="1" name=""/>
+        <p:cNvGrpSpPr/>
+        <p:nvPr/>
+      </p:nvGrpSpPr>
+      <p:grpSpPr>
+        <a:xfrm>
+          <a:off x="0" y="0"/>
+          <a:ext cx="0" cy="0"/>
+          <a:chOff x="0" y="0"/>
+          <a:chExt cx="0" cy="0"/>
+        </a:xfrm>
+      </p:grpSpPr>
+      <p:sp>
+        <p:nvSpPr>
+          <p:cNvPr id="2" name="Slide Image Placeholder 1"/>
+          <p:cNvSpPr>
+            <a:spLocks noGrp="1"/>
+          </p:cNvSpPr>
+          <p:nvPr>
+            <p:ph type="sldImg" idx="2"/>
+          </p:nvPr>
+        </p:nvSpPr>
+        <p:spPr/>
+      </p:sp>
+      <p:sp>
+        <p:nvSpPr>
+          <p:cNvPr id="3" name="Notes Placeholder 2"/>
+          <p:cNvSpPr>
+            <a:spLocks noGrp="1"/>
+          </p:cNvSpPr>
+          <p:nvPr>
+            <p:ph type="body" idx="3" sz="quarter"/>
+          </p:nvPr>
+        </p:nvSpPr>
+        <p:spPr/>
+        <p:txBody>
+          <a:bodyPr/>
+          <a:lstStyle/>
+          <a:p>
+            <a:r>
+              <a:t>ZK proofs are powerful, but they have one important limitation: they verify that inputs lead to a correct score, but they cannot verify that those inputs reflect real riding. That's the spoofing problem — and it's the main attack surface for RideTrue.</a:t>
+            </a:r>
+          </a:p>
+          <a:p/>
+          <a:p>
+            <a:r>
+              <a:t>The attack is straightforward: fake GPS coordinates, replay a clean ride on a stationary phone, or fabricate accelerometer data to earn a premium discount you don't deserve.</a:t>
+            </a:r>
+          </a:p>
+          <a:p/>
+          <a:p>
+            <a:r>
+              <a:t>Our four-layer defense: First, hardware attestation — Android Play Integrity and iOS DeviceCheck confirm the telemetry came from a genuine, uncompromised device. Second, sensor fusion — we reconstruct behavior from GPS, accelerometer, gyroscope, magnetometer, and optionally OBD. A spoofer has to forge all of them simultaneously and consistently. Third, statistical anomaly detection — we flag physically implausible signals or trajectories inconsistent with the reported speed. Fourth, random sampling — a subset of rides gets cross-checked against cell-tower triangulation and third-party traffic data.</a:t>
+            </a:r>
+          </a:p>
+          <a:p/>
+          <a:p>
+            <a:r>
+              <a:t>Our goal isn't perfect security — it's making spoofing economically irrational. If the expected penalty times detection probability exceeds the expected payoff, rational actors won't bother.</a:t>
+            </a:r>
+          </a:p>
+        </p:txBody>
+      </p:sp>
+      <p:sp>
+        <p:nvSpPr>
+          <p:cNvPr id="4" name="Slide Number Placeholder 3"/>
+          <p:cNvSpPr>
+            <a:spLocks noGrp="1"/>
+          </p:cNvSpPr>
+          <p:nvPr>
+            <p:ph type="sldNum" idx="5" sz="quarter"/>
+          </p:nvPr>
+        </p:nvSpPr>
+        <p:spPr/>
+      </p:sp>
+    </p:spTree>
+  </p:cSld>
+  <p:clrMapOvr>
+    <a:masterClrMapping/>
+  </p:clrMapOvr>
+</p:notes>
+</file>
+
+<file path=ppt/notesSlides/notesSlide8.xml><?xml version="1.0" encoding="utf-8"?>
+<p:notes xmlns:a="http://schemas.openxmlformats.org/drawingml/2006/main" xmlns:p="http://schemas.openxmlformats.org/presentationml/2006/main" xmlns:r="http://schemas.openxmlformats.org/officeDocument/2006/relationships">
+  <p:cSld>
+    <p:spTree>
+      <p:nvGrpSpPr>
+        <p:cNvPr id="1" name=""/>
+        <p:cNvGrpSpPr/>
+        <p:nvPr/>
+      </p:nvGrpSpPr>
+      <p:grpSpPr>
+        <a:xfrm>
+          <a:off x="0" y="0"/>
+          <a:ext cx="0" cy="0"/>
+          <a:chOff x="0" y="0"/>
+          <a:chExt cx="0" cy="0"/>
+        </a:xfrm>
+      </p:grpSpPr>
+      <p:sp>
+        <p:nvSpPr>
+          <p:cNvPr id="2" name="Slide Image Placeholder 1"/>
+          <p:cNvSpPr>
+            <a:spLocks noGrp="1"/>
+          </p:cNvSpPr>
+          <p:nvPr>
+            <p:ph type="sldImg" idx="2"/>
+          </p:nvPr>
+        </p:nvSpPr>
+        <p:spPr/>
+      </p:sp>
+      <p:sp>
+        <p:nvSpPr>
+          <p:cNvPr id="3" name="Notes Placeholder 2"/>
+          <p:cNvSpPr>
+            <a:spLocks noGrp="1"/>
+          </p:cNvSpPr>
+          <p:nvPr>
+            <p:ph type="body" idx="3" sz="quarter"/>
+          </p:nvPr>
+        </p:nvSpPr>
+        <p:spPr/>
+        <p:txBody>
+          <a:bodyPr/>
+          <a:lstStyle/>
+          <a:p>
+            <a:r>
+              <a:t>This slide covers the two off-chain integration problems: how claims get verified, and what happens to idle capital.</a:t>
+            </a:r>
+          </a:p>
+          <a:p/>
+          <a:p>
+            <a:r>
+              <a:t>Claims follow a four-step lifecycle. The rider files via the app — no wallet management, no gas fees, just a form and photos. Decentralized oracles then pull from repair shops, insurers, and public records. Multiple independent sources must reach consensus before the claim is valid. Then the smart contract either pays out automatically in USDC, or escalates to arbitration if there's a dispute.</a:t>
+            </a:r>
+          </a:p>
+          <a:p/>
+          <a:p>
+            <a:r>
+              <a:t>Oracle integrity: no single source is trusted. Providers stake collateral on their data — bad feeds get slashed. Stale or conflicting feeds automatically pause execution.</a:t>
+            </a:r>
+          </a:p>
+          <a:p/>
+          <a:p>
+            <a:r>
+              <a:t>DeFi composability: the idle portion of the insurance pool earns yield via Aave. We access DEX liquidity for rapid rebalancing during stress. This improves capital efficiency without compromising our ability to pay claims.</a:t>
+            </a:r>
+          </a:p>
+        </p:txBody>
+      </p:sp>
+      <p:sp>
+        <p:nvSpPr>
+          <p:cNvPr id="4" name="Slide Number Placeholder 3"/>
+          <p:cNvSpPr>
+            <a:spLocks noGrp="1"/>
+          </p:cNvSpPr>
+          <p:nvPr>
+            <p:ph type="sldNum" idx="5" sz="quarter"/>
+          </p:nvPr>
+        </p:nvSpPr>
+        <p:spPr/>
+      </p:sp>
+    </p:spTree>
+  </p:cSld>
+  <p:clrMapOvr>
+    <a:masterClrMapping/>
+  </p:clrMapOvr>
+</p:notes>
+</file>
+
+<file path=ppt/notesSlides/notesSlide9.xml><?xml version="1.0" encoding="utf-8"?>
+<p:notes xmlns:a="http://schemas.openxmlformats.org/drawingml/2006/main" xmlns:p="http://schemas.openxmlformats.org/presentationml/2006/main" xmlns:r="http://schemas.openxmlformats.org/officeDocument/2006/relationships">
+  <p:cSld>
+    <p:spTree>
+      <p:nvGrpSpPr>
+        <p:cNvPr id="1" name=""/>
+        <p:cNvGrpSpPr/>
+        <p:nvPr/>
+      </p:nvGrpSpPr>
+      <p:grpSpPr>
+        <a:xfrm>
+          <a:off x="0" y="0"/>
+          <a:ext cx="0" cy="0"/>
+          <a:chOff x="0" y="0"/>
+          <a:chExt cx="0" cy="0"/>
+        </a:xfrm>
+      </p:grpSpPr>
+      <p:sp>
+        <p:nvSpPr>
+          <p:cNvPr id="2" name="Slide Image Placeholder 1"/>
+          <p:cNvSpPr>
+            <a:spLocks noGrp="1"/>
+          </p:cNvSpPr>
+          <p:nvPr>
+            <p:ph type="sldImg" idx="2"/>
+          </p:nvPr>
+        </p:nvSpPr>
+        <p:spPr/>
+      </p:sp>
+      <p:sp>
+        <p:nvSpPr>
+          <p:cNvPr id="3" name="Notes Placeholder 2"/>
+          <p:cNvSpPr>
+            <a:spLocks noGrp="1"/>
+          </p:cNvSpPr>
+          <p:nvPr>
+            <p:ph type="body" idx="3" sz="quarter"/>
+          </p:nvPr>
+        </p:nvSpPr>
+        <p:spPr/>
+        <p:txBody>
+          <a:bodyPr/>
+          <a:lstStyle/>
+          <a:p>
+            <a:r>
+              <a:t>The biggest barrier to adoption isn't technical feasibility. It's user friction. If someone has to understand what a wallet or a private key is, we've already lost them.</a:t>
+            </a:r>
+          </a:p>
+          <a:p/>
+          <a:p>
+            <a:r>
+              <a:t>So we abstract all of that. Account abstraction means users sign up with email or social login — wallets are generated in the background. Gas abstraction means users never need to hold native tokens.</a:t>
+            </a:r>
+          </a:p>
+          <a:p/>
+          <a:p>
+            <a:r>
+              <a:t>The interface is different for each user type. Riders get a passive dashboard: your safety score, your premium, your projected rebate. The app tracks behavior in the background. For mechanics, we're targeting sub-30-second service entries — structured forms or QR-based vehicle ID, optimized for speed at the shop counter. For buyers checking a used bike, it's one scan or one VIN entry — full verifiable history, no account required to read.</a:t>
+            </a:r>
+          </a:p>
+          <a:p/>
+          <a:p>
+            <a:r>
+              <a:t>The design principle we keep coming back to: if the user has to know it's blockchain, the design has failed.</a:t>
+            </a:r>
+          </a:p>
+        </p:txBody>
+      </p:sp>
+      <p:sp>
+        <p:nvSpPr>
+          <p:cNvPr id="4" name="Slide Number Placeholder 3"/>
+          <p:cNvSpPr>
+            <a:spLocks noGrp="1"/>
+          </p:cNvSpPr>
+          <p:nvPr>
+            <p:ph type="sldNum" idx="5" sz="quarter"/>
+          </p:nvPr>
+        </p:nvSpPr>
+        <p:spPr/>
+      </p:sp>
+    </p:spTree>
+  </p:cSld>
+  <p:clrMapOvr>
+    <a:masterClrMapping/>
+  </p:clrMapOvr>
+</p:notes>
 </file>
 
 <file path=ppt/slideLayouts/slideLayout1.xml><?xml version="1.0" encoding="utf-8"?>

</xml_diff>